<commit_message>
Fix tier numbering and ATC variants in 05.03 and 05.05 decks
The source PDFs labeled ABAP Cloud as Tier 2 and the wrapper as Tier 3.
SAP's model (and the lesson READMEs) use Tier 1 = ABAP Cloud,
Tier 2 = Cloud API Enablement (wrapper), Tier 3 = classic ABAP.

Also replaces SAP_CP_READINESS_REMOTE with ABAP_CLOUD_READINESS /
ABAP_CLOUD_DEVELOPMENT_DEFAULT and adds a slide on the 2025 clean core
levels A-D that succeed the 3-tier model.

Co-Authored-By: Claude Opus 5.5 <noreply@anthropic.com>
</commit_message>
<xml_diff>
--- a/modulo-05/05.03 - ABAP Cloud em Profundidade/05.03_ABAP_Cloud_Guia_Arquitetural.pptx
+++ b/modulo-05/05.03 - ABAP Cloud em Profundidade/05.03_ABAP_Cloud_Guia_Arquitetural.pptx
@@ -3570,7 +3570,7 @@
                   <a:srgbClr val="0064D9"/>
                 </a:solidFill>
               </a:rPr>
-              <a:t>Tier 2 · ABAP Cloud</a:t>
+              <a:t>Tier 1 · ABAP Cloud</a:t>
             </a:r>
             <a:endParaRPr lang="en-US" sz="1500" dirty="0"/>
           </a:p>
@@ -3869,7 +3869,7 @@
                   <a:srgbClr val="556B82"/>
                 </a:solidFill>
               </a:rPr>
-              <a:t>Interface limpa, tipos simples</a:t>
+              <a:t>Tier 2 · Cloud API Enablement</a:t>
             </a:r>
             <a:endParaRPr lang="en-US" sz="1200" dirty="0"/>
           </a:p>
@@ -4608,7 +4608,7 @@
                   <a:srgbClr val="556B82"/>
                 </a:solidFill>
               </a:rPr>
-              <a:t>Agora seu código ABAP Cloud (Tier 2), como o seu app Fiori moderno, pode instanciar e chamar a classe Wrapper de forma segura e sem erros de sintaxe.</a:t>
+              <a:t>Agora seu código ABAP Cloud (Tier 1), como o seu app Fiori moderno, pode instanciar e chamar a classe Wrapper de forma segura e sem erros de sintaxe.</a:t>
             </a:r>
             <a:endParaRPr lang="en-US" sz="1600" dirty="0"/>
           </a:p>
@@ -5604,7 +5604,7 @@
         </p:blipFill>
         <p:spPr>
           <a:xfrm>
-            <a:off x="6507328" y="4581144"/>
+            <a:off x="777240" y="4581144"/>
             <a:ext cx="347472" cy="347472"/>
           </a:xfrm>
           <a:prstGeom prst="rect">
@@ -5628,7 +5628,7 @@
         </p:blipFill>
         <p:spPr>
           <a:xfrm>
-            <a:off x="777240" y="4581144"/>
+            <a:off x="6507328" y="4581144"/>
             <a:ext cx="347472" cy="347472"/>
           </a:xfrm>
           <a:prstGeom prst="rect">
@@ -15262,7 +15262,7 @@
                   <a:srgbClr val="0064D9"/>
                 </a:solidFill>
               </a:rPr>
-              <a:t>Tier 2</a:t>
+              <a:t>Tier 1</a:t>
             </a:r>
             <a:endParaRPr lang="en-US" sz="1300" dirty="0"/>
           </a:p>

</xml_diff>